<commit_message>
面试PPT：DeepFM AUC 0.804 → 0.754（时间切分）
</commit_message>
<xml_diff>
--- a/docs/interview/Recsys_Interview_Deck_CN.pptx
+++ b/docs/interview/Recsys_Interview_Deck_CN.pptx
@@ -2127,6 +2127,10 @@
             <a:prstDash val="solid"/>
           </a:ln>
         </p:spPr>
+        <p:txBody xmlns:a="http://schemas.openxmlformats.org/drawingml/2006/main">
+          <a:bodyPr/>
+          <a:p/>
+        </p:txBody>
       </p:sp>
       <p:sp>
         <p:nvSpPr>
@@ -2618,6 +2622,10 @@
             <a:prstDash val="solid"/>
           </a:ln>
         </p:spPr>
+        <p:txBody xmlns:a="http://schemas.openxmlformats.org/drawingml/2006/main">
+          <a:bodyPr/>
+          <a:p/>
+        </p:txBody>
       </p:sp>
       <p:sp>
         <p:nvSpPr>
@@ -2651,6 +2659,10 @@
             <a:prstDash val="solid"/>
           </a:ln>
         </p:spPr>
+        <p:txBody xmlns:a="http://schemas.openxmlformats.org/drawingml/2006/main">
+          <a:bodyPr/>
+          <a:p/>
+        </p:txBody>
       </p:sp>
       <p:sp>
         <p:nvSpPr>
@@ -2684,6 +2696,10 @@
             <a:prstDash val="solid"/>
           </a:ln>
         </p:spPr>
+        <p:txBody xmlns:a="http://schemas.openxmlformats.org/drawingml/2006/main">
+          <a:bodyPr/>
+          <a:p/>
+        </p:txBody>
       </p:sp>
       <p:sp>
         <p:nvSpPr>
@@ -2717,6 +2733,10 @@
             <a:prstDash val="solid"/>
           </a:ln>
         </p:spPr>
+        <p:txBody xmlns:a="http://schemas.openxmlformats.org/drawingml/2006/main">
+          <a:bodyPr/>
+          <a:p/>
+        </p:txBody>
       </p:sp>
       <p:sp>
         <p:nvSpPr>
@@ -2752,6 +2772,10 @@
             <a:prstDash val="solid"/>
           </a:ln>
         </p:spPr>
+        <p:txBody xmlns:a="http://schemas.openxmlformats.org/drawingml/2006/main">
+          <a:bodyPr/>
+          <a:p/>
+        </p:txBody>
       </p:sp>
       <p:sp>
         <p:nvSpPr>
@@ -2984,6 +3008,10 @@
             <a:prstDash val="solid"/>
           </a:ln>
         </p:spPr>
+        <p:txBody xmlns:a="http://schemas.openxmlformats.org/drawingml/2006/main">
+          <a:bodyPr/>
+          <a:p/>
+        </p:txBody>
       </p:sp>
       <p:sp>
         <p:nvSpPr>
@@ -3216,6 +3244,10 @@
             <a:prstDash val="solid"/>
           </a:ln>
         </p:spPr>
+        <p:txBody xmlns:a="http://schemas.openxmlformats.org/drawingml/2006/main">
+          <a:bodyPr/>
+          <a:p/>
+        </p:txBody>
       </p:sp>
       <p:sp>
         <p:nvSpPr>
@@ -3448,6 +3480,10 @@
             <a:prstDash val="solid"/>
           </a:ln>
         </p:spPr>
+        <p:txBody xmlns:a="http://schemas.openxmlformats.org/drawingml/2006/main">
+          <a:bodyPr/>
+          <a:p/>
+        </p:txBody>
       </p:sp>
       <p:sp>
         <p:nvSpPr>
@@ -3939,6 +3975,10 @@
             <a:prstDash val="solid"/>
           </a:ln>
         </p:spPr>
+        <p:txBody xmlns:a="http://schemas.openxmlformats.org/drawingml/2006/main">
+          <a:bodyPr/>
+          <a:p/>
+        </p:txBody>
       </p:sp>
       <p:pic>
         <p:nvPicPr>
@@ -4510,6 +4550,10 @@
             <a:prstDash val="solid"/>
           </a:ln>
         </p:spPr>
+        <p:txBody xmlns:a="http://schemas.openxmlformats.org/drawingml/2006/main">
+          <a:bodyPr/>
+          <a:p/>
+        </p:txBody>
       </p:sp>
       <p:sp>
         <p:nvSpPr>
@@ -4543,6 +4587,10 @@
             <a:prstDash val="solid"/>
           </a:ln>
         </p:spPr>
+        <p:txBody xmlns:a="http://schemas.openxmlformats.org/drawingml/2006/main">
+          <a:bodyPr/>
+          <a:p/>
+        </p:txBody>
       </p:sp>
       <p:sp>
         <p:nvSpPr>
@@ -4578,6 +4626,10 @@
             <a:prstDash val="solid"/>
           </a:ln>
         </p:spPr>
+        <p:txBody xmlns:a="http://schemas.openxmlformats.org/drawingml/2006/main">
+          <a:bodyPr/>
+          <a:p/>
+        </p:txBody>
       </p:sp>
       <p:sp>
         <p:nvSpPr>
@@ -4613,6 +4665,10 @@
             <a:prstDash val="solid"/>
           </a:ln>
         </p:spPr>
+        <p:txBody xmlns:a="http://schemas.openxmlformats.org/drawingml/2006/main">
+          <a:bodyPr/>
+          <a:p/>
+        </p:txBody>
       </p:sp>
       <p:sp>
         <p:nvSpPr>
@@ -4933,7 +4989,7 @@
                 <a:ea typeface="Microsoft YaHei"/>
                 <a:cs typeface="Microsoft YaHei"/>
               </a:rPr>
-              <a:t>测试 AUC 0.804</a:t>
+              <a:t>测试 AUC 0.754</a:t>
             </a:r>
           </a:p>
         </p:txBody>
@@ -5347,6 +5403,10 @@
             <a:prstDash val="solid"/>
           </a:ln>
         </p:spPr>
+        <p:txBody xmlns:a="http://schemas.openxmlformats.org/drawingml/2006/main">
+          <a:bodyPr/>
+          <a:p/>
+        </p:txBody>
       </p:sp>
       <p:pic>
         <p:nvPicPr>
@@ -5918,6 +5978,10 @@
             <a:prstDash val="solid"/>
           </a:ln>
         </p:spPr>
+        <p:txBody xmlns:a="http://schemas.openxmlformats.org/drawingml/2006/main">
+          <a:bodyPr/>
+          <a:p/>
+        </p:txBody>
       </p:sp>
       <p:pic>
         <p:nvPicPr>
@@ -6512,6 +6576,10 @@
             <a:prstDash val="solid"/>
           </a:ln>
         </p:spPr>
+        <p:txBody xmlns:a="http://schemas.openxmlformats.org/drawingml/2006/main">
+          <a:bodyPr/>
+          <a:p/>
+        </p:txBody>
       </p:sp>
       <p:sp>
         <p:nvSpPr>
@@ -6545,6 +6613,10 @@
             <a:prstDash val="solid"/>
           </a:ln>
         </p:spPr>
+        <p:txBody xmlns:a="http://schemas.openxmlformats.org/drawingml/2006/main">
+          <a:bodyPr/>
+          <a:p/>
+        </p:txBody>
       </p:sp>
       <p:sp>
         <p:nvSpPr>
@@ -6578,6 +6650,10 @@
             <a:prstDash val="solid"/>
           </a:ln>
         </p:spPr>
+        <p:txBody xmlns:a="http://schemas.openxmlformats.org/drawingml/2006/main">
+          <a:bodyPr/>
+          <a:p/>
+        </p:txBody>
       </p:sp>
       <p:sp>
         <p:nvSpPr>
@@ -6611,6 +6687,10 @@
             <a:prstDash val="solid"/>
           </a:ln>
         </p:spPr>
+        <p:txBody xmlns:a="http://schemas.openxmlformats.org/drawingml/2006/main">
+          <a:bodyPr/>
+          <a:p/>
+        </p:txBody>
       </p:sp>
       <p:sp>
         <p:nvSpPr>
@@ -6646,6 +6726,10 @@
             <a:prstDash val="solid"/>
           </a:ln>
         </p:spPr>
+        <p:txBody xmlns:a="http://schemas.openxmlformats.org/drawingml/2006/main">
+          <a:bodyPr/>
+          <a:p/>
+        </p:txBody>
       </p:sp>
       <p:sp>
         <p:nvSpPr>
@@ -6820,6 +6904,10 @@
             <a:prstDash val="solid"/>
           </a:ln>
         </p:spPr>
+        <p:txBody xmlns:a="http://schemas.openxmlformats.org/drawingml/2006/main">
+          <a:bodyPr/>
+          <a:p/>
+        </p:txBody>
       </p:sp>
       <p:sp>
         <p:nvSpPr>
@@ -6994,6 +7082,10 @@
             <a:prstDash val="solid"/>
           </a:ln>
         </p:spPr>
+        <p:txBody xmlns:a="http://schemas.openxmlformats.org/drawingml/2006/main">
+          <a:bodyPr/>
+          <a:p/>
+        </p:txBody>
       </p:sp>
       <p:sp>
         <p:nvSpPr>
@@ -7168,6 +7260,10 @@
             <a:prstDash val="solid"/>
           </a:ln>
         </p:spPr>
+        <p:txBody xmlns:a="http://schemas.openxmlformats.org/drawingml/2006/main">
+          <a:bodyPr/>
+          <a:p/>
+        </p:txBody>
       </p:sp>
       <p:sp>
         <p:nvSpPr>
@@ -7601,6 +7697,10 @@
             <a:prstDash val="solid"/>
           </a:ln>
         </p:spPr>
+        <p:txBody xmlns:a="http://schemas.openxmlformats.org/drawingml/2006/main">
+          <a:bodyPr/>
+          <a:p/>
+        </p:txBody>
       </p:sp>
       <p:graphicFrame>
         <p:nvGraphicFramePr>
@@ -8562,6 +8662,10 @@
             <a:prstDash val="solid"/>
           </a:ln>
         </p:spPr>
+        <p:txBody xmlns:a="http://schemas.openxmlformats.org/drawingml/2006/main">
+          <a:bodyPr/>
+          <a:p/>
+        </p:txBody>
       </p:sp>
       <p:sp>
         <p:nvSpPr>

</xml_diff>